<commit_message>
Weeks 1-2: citations and week numbers updated; Week 3 notebook linked
Lecture 1 and 2 notes cite "Author et al. (year)"; Lecture 2 quotes
Jelinek in his own words; the Lecture 2 slides follow the current
course plan (attention in Week 3, the Transformer in Week 4). The Week 3
hands-on line links the notebook, and Week 4 is the current week.

Co-Authored-By: Claude Opus 5.5 <noreply@anthropic.com>
Claude-Session: https://claude.ai/code/session_01LVQ4w2zY5FCz63H57dcxRD
</commit_message>
<xml_diff>
--- a/materials/week-02/lecture-02-slides.pptx
+++ b/materials/week-02/lecture-02-slides.pptx
@@ -1680,7 +1680,7 @@
           <a:lstStyle/>
           <a:p>
             <a:r>
-              <a:t>Notes §5, 'What similarity captures, and what it misses'. Antonyms keep the same company (hot/cold 0.64 &gt; happy/glad 0.38). One vector per word type: bank blends the river and the money. The fix is a vector per occurrence, computed from the context: ELMo (2018) with LSTMs; attention in the Transformer (Week 3). Break after this slide.</a:t>
+              <a:t>Notes §5, 'What similarity captures, and what it misses'. Antonyms keep the same company (hot/cold 0.64 &gt; happy/glad 0.38). One vector per word type: bank blends the river and the money. The fix is a vector per occurrence, computed from the context: ELMo (2018) with LSTMs; attention (Week 3) and the Transformer (Week 4). Break after this slide.</a:t>
             </a:r>
           </a:p>
         </p:txBody>
@@ -2310,7 +2310,7 @@
           <a:lstStyle/>
           <a:p>
             <a:r>
-              <a:t>History, one step per slide as in Lecture 1. Vaswani et al. (2017). GPT and BERT (2018) are Transformers; Google Translate's encoder became one in 2020. Week 3. Pictures, Wikimedia Commons: Transformer, full architecture.png (dvgodoy, CC BY 4.0).</a:t>
+              <a:t>History, one step per slide as in Lecture 1. Vaswani et al. (2017). GPT and BERT (2018) are Transformers; Google Translate's encoder became one in 2020. Week 4. Pictures, Wikimedia Commons: Transformer, full architecture.png (dvgodoy, CC BY 4.0).</a:t>
             </a:r>
           </a:p>
         </p:txBody>
@@ -3150,7 +3150,7 @@
           <a:lstStyle/>
           <a:p>
             <a:r>
-              <a:t>The fix that recurs across deep learning. LSTM (Hochreiter and Schmidhuber 1997), whose cell had no forget gate: c_t = c_{t−1} + i_t ⊙ g_t, the 'constant error carousel'. Highway networks (Srivastava, Greff, and Schmidhuber, May 2015): LSTM-style gates across layers. ResNet (He, Zhang, Ren, and Sun, December 2015): x + F(x), 152 layers, won ImageNet 2015. Every Transformer layer has two residual connections (Week 3). Pictures, Wikimedia Commons: ResBlock.png (LunarLullaby, CC BY-SA 4.0).</a:t>
+              <a:t>The fix that recurs across deep learning. LSTM (Hochreiter and Schmidhuber 1997), whose cell had no forget gate: c_t = c_{t−1} + i_t ⊙ g_t, the 'constant error carousel'. Highway networks (Srivastava, Greff, and Schmidhuber, May 2015): LSTM-style gates across layers. ResNet (He, Zhang, Ren, and Sun, December 2015): x + F(x), 152 layers, won ImageNet 2015. Every Transformer layer has two residual connections (Week 4). Pictures, Wikimedia Commons: ResBlock.png (LunarLullaby, CC BY-SA 4.0).</a:t>
             </a:r>
           </a:p>
         </p:txBody>
@@ -3780,7 +3780,7 @@
           <a:lstStyle/>
           <a:p>
             <a:r>
-              <a:t>Notes §8, last subsection. Encoder–decoder LSTMs (2014) squeezed a sentence into one vector and got worse on long sentences; Bahdanau, Cho, and Bengio (2015) let the decoder look back at all encoder states: attention. And h_t waits for h_{t−1}: no parallelism over time. Week 3: attention without recurrence.</a:t>
+              <a:t>Notes §8, last subsection. Encoder–decoder LSTMs (2014) squeezed a sentence into one vector and got worse on long sentences; Bahdanau, Cho, and Bengio (2015) let the decoder look back at all encoder states: attention. And h_t waits for h_{t−1}: no parallelism over time. Week 3: attention; Week 4: the Transformer, attention without recurrence.</a:t>
             </a:r>
           </a:p>
         </p:txBody>
@@ -3920,7 +3920,7 @@
           <a:lstStyle/>
           <a:p>
             <a:r>
-              <a:t>Notes §1, 'Tokens: characters, words, or pieces', Figure 1. Shannon used letters and words; models choose a vocabulary of tokens. Characters: 33 plus the end symbol. Words: 8,681 with &lt;unk&gt; and EOS. GPT-2: 50,257 byte-level pieces (Week 4). Frequent words stay whole, rare words are split.</a:t>
+              <a:t>Notes §1, 'Tokens: characters, words, or pieces', Figure 1. Shannon used letters and words; models choose a vocabulary of tokens. Characters: 33 plus the end symbol. Words: 8,681 with &lt;unk&gt; and EOS. GPT-2: 50,257 byte-level pieces (Week 5). Frequent words stay whole, rare words are split.</a:t>
             </a:r>
           </a:p>
         </p:txBody>
@@ -28262,7 +28262,7 @@
                 </a:solidFill>
                 <a:latin typeface="Calibri"/>
               </a:rPr>
-              <a:t>→ attention, the Transformer (Week 3)</a:t>
+              <a:t>→ attention (Week 3), the Transformer (Week 4)</a:t>
             </a:r>
           </a:p>
         </p:txBody>

</xml_diff>